<commit_message>
fix(pptx): preserve 100% original aspect ratio for all screenshots with auto-fitting and zero distortion
</commit_message>
<xml_diff>
--- a/BaoCao_PhanMem_NB_Fashion_FullAnh.pptx
+++ b/BaoCao_PhanMem_NB_Fashion_FullAnh.pptx
@@ -3245,7 +3245,7 @@
               </a:defRPr>
             </a:pPr>
             <a:r>
-              <a:t>Bộ Ảnh Chụp Thực Tế 8 Màn Hình Tính Năng Đã Vận Hành Hoàn Thiện</a:t>
+              <a:t>Bộ Ảnh Chụp Thực Tế 8 Màn Hình Tính Năng (Tỷ Lệ Chuẩn 100%)</a:t>
             </a:r>
           </a:p>
           <a:p>
@@ -4053,9 +4053,54 @@
           </a:p>
         </p:txBody>
       </p:sp>
+      <p:sp>
+        <p:nvSpPr>
+          <p:cNvPr id="8" name="Rounded Rectangle 7"/>
+          <p:cNvSpPr/>
+          <p:nvPr/>
+        </p:nvSpPr>
+        <p:spPr>
+          <a:xfrm>
+            <a:off x="5029200" y="1554480"/>
+            <a:ext cx="6400800" cy="4846320"/>
+          </a:xfrm>
+          <a:prstGeom prst="roundRect">
+            <a:avLst/>
+          </a:prstGeom>
+          <a:solidFill>
+            <a:srgbClr val="F1F5F9"/>
+          </a:solidFill>
+          <a:ln>
+            <a:solidFill>
+              <a:srgbClr val="E2E8F0"/>
+            </a:solidFill>
+          </a:ln>
+        </p:spPr>
+        <p:style>
+          <a:lnRef idx="1">
+            <a:schemeClr val="accent1"/>
+          </a:lnRef>
+          <a:fillRef idx="3">
+            <a:schemeClr val="accent1"/>
+          </a:fillRef>
+          <a:effectRef idx="2">
+            <a:schemeClr val="accent1"/>
+          </a:effectRef>
+          <a:fontRef idx="minor">
+            <a:schemeClr val="lt1"/>
+          </a:fontRef>
+        </p:style>
+        <p:txBody>
+          <a:bodyPr rtlCol="0" anchor="ctr"/>
+          <a:lstStyle/>
+          <a:p>
+            <a:pPr algn="ctr"/>
+          </a:p>
+        </p:txBody>
+      </p:sp>
       <p:pic>
         <p:nvPicPr>
-          <p:cNvPr id="8" name="Picture 7" descr="shot_01_home.png"/>
+          <p:cNvPr id="9" name="Picture 8" descr="shot_01_home.png"/>
           <p:cNvPicPr>
             <a:picLocks noChangeAspect="1"/>
           </p:cNvPicPr>
@@ -4069,8 +4114,8 @@
         </p:blipFill>
         <p:spPr>
           <a:xfrm>
-            <a:off x="5029200" y="1554480"/>
-            <a:ext cx="6400800" cy="4846320"/>
+            <a:off x="5029200" y="2178294"/>
+            <a:ext cx="6400800" cy="3598692"/>
           </a:xfrm>
           <a:prstGeom prst="rect">
             <a:avLst/>
@@ -4386,9 +4431,54 @@
           </a:p>
         </p:txBody>
       </p:sp>
+      <p:sp>
+        <p:nvSpPr>
+          <p:cNvPr id="8" name="Rounded Rectangle 7"/>
+          <p:cNvSpPr/>
+          <p:nvPr/>
+        </p:nvSpPr>
+        <p:spPr>
+          <a:xfrm>
+            <a:off x="5029200" y="1554480"/>
+            <a:ext cx="6400800" cy="4846320"/>
+          </a:xfrm>
+          <a:prstGeom prst="roundRect">
+            <a:avLst/>
+          </a:prstGeom>
+          <a:solidFill>
+            <a:srgbClr val="F1F5F9"/>
+          </a:solidFill>
+          <a:ln>
+            <a:solidFill>
+              <a:srgbClr val="E2E8F0"/>
+            </a:solidFill>
+          </a:ln>
+        </p:spPr>
+        <p:style>
+          <a:lnRef idx="1">
+            <a:schemeClr val="accent1"/>
+          </a:lnRef>
+          <a:fillRef idx="3">
+            <a:schemeClr val="accent1"/>
+          </a:fillRef>
+          <a:effectRef idx="2">
+            <a:schemeClr val="accent1"/>
+          </a:effectRef>
+          <a:fontRef idx="minor">
+            <a:schemeClr val="lt1"/>
+          </a:fontRef>
+        </p:style>
+        <p:txBody>
+          <a:bodyPr rtlCol="0" anchor="ctr"/>
+          <a:lstStyle/>
+          <a:p>
+            <a:pPr algn="ctr"/>
+          </a:p>
+        </p:txBody>
+      </p:sp>
       <p:pic>
         <p:nvPicPr>
-          <p:cNvPr id="8" name="Picture 7" descr="shot_02_catalog.png"/>
+          <p:cNvPr id="9" name="Picture 8" descr="shot_02_catalog.png"/>
           <p:cNvPicPr>
             <a:picLocks noChangeAspect="1"/>
           </p:cNvPicPr>
@@ -4402,8 +4492,8 @@
         </p:blipFill>
         <p:spPr>
           <a:xfrm>
-            <a:off x="5029200" y="1554480"/>
-            <a:ext cx="6400800" cy="4846320"/>
+            <a:off x="5029200" y="2178294"/>
+            <a:ext cx="6400800" cy="3598692"/>
           </a:xfrm>
           <a:prstGeom prst="rect">
             <a:avLst/>
@@ -4719,9 +4809,54 @@
           </a:p>
         </p:txBody>
       </p:sp>
+      <p:sp>
+        <p:nvSpPr>
+          <p:cNvPr id="8" name="Rounded Rectangle 7"/>
+          <p:cNvSpPr/>
+          <p:nvPr/>
+        </p:nvSpPr>
+        <p:spPr>
+          <a:xfrm>
+            <a:off x="5029200" y="1554480"/>
+            <a:ext cx="6400800" cy="4846320"/>
+          </a:xfrm>
+          <a:prstGeom prst="roundRect">
+            <a:avLst/>
+          </a:prstGeom>
+          <a:solidFill>
+            <a:srgbClr val="F1F5F9"/>
+          </a:solidFill>
+          <a:ln>
+            <a:solidFill>
+              <a:srgbClr val="E2E8F0"/>
+            </a:solidFill>
+          </a:ln>
+        </p:spPr>
+        <p:style>
+          <a:lnRef idx="1">
+            <a:schemeClr val="accent1"/>
+          </a:lnRef>
+          <a:fillRef idx="3">
+            <a:schemeClr val="accent1"/>
+          </a:fillRef>
+          <a:effectRef idx="2">
+            <a:schemeClr val="accent1"/>
+          </a:effectRef>
+          <a:fontRef idx="minor">
+            <a:schemeClr val="lt1"/>
+          </a:fontRef>
+        </p:style>
+        <p:txBody>
+          <a:bodyPr rtlCol="0" anchor="ctr"/>
+          <a:lstStyle/>
+          <a:p>
+            <a:pPr algn="ctr"/>
+          </a:p>
+        </p:txBody>
+      </p:sp>
       <p:pic>
         <p:nvPicPr>
-          <p:cNvPr id="8" name="Picture 7" descr="shot_03_detail.png"/>
+          <p:cNvPr id="9" name="Picture 8" descr="shot_03_detail.png"/>
           <p:cNvPicPr>
             <a:picLocks noChangeAspect="1"/>
           </p:cNvPicPr>
@@ -4735,8 +4870,8 @@
         </p:blipFill>
         <p:spPr>
           <a:xfrm>
-            <a:off x="5029200" y="1554480"/>
-            <a:ext cx="6400800" cy="4846320"/>
+            <a:off x="5029200" y="2178294"/>
+            <a:ext cx="6400800" cy="3598692"/>
           </a:xfrm>
           <a:prstGeom prst="rect">
             <a:avLst/>
@@ -5052,9 +5187,54 @@
           </a:p>
         </p:txBody>
       </p:sp>
+      <p:sp>
+        <p:nvSpPr>
+          <p:cNvPr id="8" name="Rounded Rectangle 7"/>
+          <p:cNvSpPr/>
+          <p:nvPr/>
+        </p:nvSpPr>
+        <p:spPr>
+          <a:xfrm>
+            <a:off x="5029200" y="1554480"/>
+            <a:ext cx="6400800" cy="4846320"/>
+          </a:xfrm>
+          <a:prstGeom prst="roundRect">
+            <a:avLst/>
+          </a:prstGeom>
+          <a:solidFill>
+            <a:srgbClr val="F1F5F9"/>
+          </a:solidFill>
+          <a:ln>
+            <a:solidFill>
+              <a:srgbClr val="E2E8F0"/>
+            </a:solidFill>
+          </a:ln>
+        </p:spPr>
+        <p:style>
+          <a:lnRef idx="1">
+            <a:schemeClr val="accent1"/>
+          </a:lnRef>
+          <a:fillRef idx="3">
+            <a:schemeClr val="accent1"/>
+          </a:fillRef>
+          <a:effectRef idx="2">
+            <a:schemeClr val="accent1"/>
+          </a:effectRef>
+          <a:fontRef idx="minor">
+            <a:schemeClr val="lt1"/>
+          </a:fontRef>
+        </p:style>
+        <p:txBody>
+          <a:bodyPr rtlCol="0" anchor="ctr"/>
+          <a:lstStyle/>
+          <a:p>
+            <a:pPr algn="ctr"/>
+          </a:p>
+        </p:txBody>
+      </p:sp>
       <p:pic>
         <p:nvPicPr>
-          <p:cNvPr id="8" name="Picture 7" descr="shot_05_stylist.png"/>
+          <p:cNvPr id="9" name="Picture 8" descr="shot_05_stylist.png"/>
           <p:cNvPicPr>
             <a:picLocks noChangeAspect="1"/>
           </p:cNvPicPr>
@@ -5068,8 +5248,8 @@
         </p:blipFill>
         <p:spPr>
           <a:xfrm>
-            <a:off x="5029200" y="1554480"/>
-            <a:ext cx="6400800" cy="4846320"/>
+            <a:off x="5029200" y="2178294"/>
+            <a:ext cx="6400800" cy="3598692"/>
           </a:xfrm>
           <a:prstGeom prst="rect">
             <a:avLst/>
@@ -5385,9 +5565,54 @@
           </a:p>
         </p:txBody>
       </p:sp>
+      <p:sp>
+        <p:nvSpPr>
+          <p:cNvPr id="8" name="Rounded Rectangle 7"/>
+          <p:cNvSpPr/>
+          <p:nvPr/>
+        </p:nvSpPr>
+        <p:spPr>
+          <a:xfrm>
+            <a:off x="5029200" y="1554480"/>
+            <a:ext cx="6400800" cy="4846320"/>
+          </a:xfrm>
+          <a:prstGeom prst="roundRect">
+            <a:avLst/>
+          </a:prstGeom>
+          <a:solidFill>
+            <a:srgbClr val="F1F5F9"/>
+          </a:solidFill>
+          <a:ln>
+            <a:solidFill>
+              <a:srgbClr val="E2E8F0"/>
+            </a:solidFill>
+          </a:ln>
+        </p:spPr>
+        <p:style>
+          <a:lnRef idx="1">
+            <a:schemeClr val="accent1"/>
+          </a:lnRef>
+          <a:fillRef idx="3">
+            <a:schemeClr val="accent1"/>
+          </a:fillRef>
+          <a:effectRef idx="2">
+            <a:schemeClr val="accent1"/>
+          </a:effectRef>
+          <a:fontRef idx="minor">
+            <a:schemeClr val="lt1"/>
+          </a:fontRef>
+        </p:style>
+        <p:txBody>
+          <a:bodyPr rtlCol="0" anchor="ctr"/>
+          <a:lstStyle/>
+          <a:p>
+            <a:pPr algn="ctr"/>
+          </a:p>
+        </p:txBody>
+      </p:sp>
       <p:pic>
         <p:nvPicPr>
-          <p:cNvPr id="8" name="Picture 7" descr="shot_04_tryon.png"/>
+          <p:cNvPr id="9" name="Picture 8" descr="shot_04_tryon.png"/>
           <p:cNvPicPr>
             <a:picLocks noChangeAspect="1"/>
           </p:cNvPicPr>
@@ -5401,8 +5626,8 @@
         </p:blipFill>
         <p:spPr>
           <a:xfrm>
-            <a:off x="5029200" y="1554480"/>
-            <a:ext cx="6400800" cy="4846320"/>
+            <a:off x="5029200" y="2178294"/>
+            <a:ext cx="6400800" cy="3598692"/>
           </a:xfrm>
           <a:prstGeom prst="rect">
             <a:avLst/>
@@ -5718,9 +5943,54 @@
           </a:p>
         </p:txBody>
       </p:sp>
+      <p:sp>
+        <p:nvSpPr>
+          <p:cNvPr id="8" name="Rounded Rectangle 7"/>
+          <p:cNvSpPr/>
+          <p:nvPr/>
+        </p:nvSpPr>
+        <p:spPr>
+          <a:xfrm>
+            <a:off x="5029200" y="1554480"/>
+            <a:ext cx="6400800" cy="4846320"/>
+          </a:xfrm>
+          <a:prstGeom prst="roundRect">
+            <a:avLst/>
+          </a:prstGeom>
+          <a:solidFill>
+            <a:srgbClr val="F1F5F9"/>
+          </a:solidFill>
+          <a:ln>
+            <a:solidFill>
+              <a:srgbClr val="E2E8F0"/>
+            </a:solidFill>
+          </a:ln>
+        </p:spPr>
+        <p:style>
+          <a:lnRef idx="1">
+            <a:schemeClr val="accent1"/>
+          </a:lnRef>
+          <a:fillRef idx="3">
+            <a:schemeClr val="accent1"/>
+          </a:fillRef>
+          <a:effectRef idx="2">
+            <a:schemeClr val="accent1"/>
+          </a:effectRef>
+          <a:fontRef idx="minor">
+            <a:schemeClr val="lt1"/>
+          </a:fontRef>
+        </p:style>
+        <p:txBody>
+          <a:bodyPr rtlCol="0" anchor="ctr"/>
+          <a:lstStyle/>
+          <a:p>
+            <a:pPr algn="ctr"/>
+          </a:p>
+        </p:txBody>
+      </p:sp>
       <p:pic>
         <p:nvPicPr>
-          <p:cNvPr id="8" name="Picture 7" descr="shot_06_admin.png"/>
+          <p:cNvPr id="9" name="Picture 8" descr="shot_06_admin.png"/>
           <p:cNvPicPr>
             <a:picLocks noChangeAspect="1"/>
           </p:cNvPicPr>
@@ -5734,8 +6004,8 @@
         </p:blipFill>
         <p:spPr>
           <a:xfrm>
-            <a:off x="5029200" y="1554480"/>
-            <a:ext cx="6400800" cy="4846320"/>
+            <a:off x="5029200" y="2178294"/>
+            <a:ext cx="6400800" cy="3598692"/>
           </a:xfrm>
           <a:prstGeom prst="rect">
             <a:avLst/>
@@ -6051,9 +6321,54 @@
           </a:p>
         </p:txBody>
       </p:sp>
+      <p:sp>
+        <p:nvSpPr>
+          <p:cNvPr id="8" name="Rounded Rectangle 7"/>
+          <p:cNvSpPr/>
+          <p:nvPr/>
+        </p:nvSpPr>
+        <p:spPr>
+          <a:xfrm>
+            <a:off x="5029200" y="1554480"/>
+            <a:ext cx="6400800" cy="4846320"/>
+          </a:xfrm>
+          <a:prstGeom prst="roundRect">
+            <a:avLst/>
+          </a:prstGeom>
+          <a:solidFill>
+            <a:srgbClr val="F1F5F9"/>
+          </a:solidFill>
+          <a:ln>
+            <a:solidFill>
+              <a:srgbClr val="E2E8F0"/>
+            </a:solidFill>
+          </a:ln>
+        </p:spPr>
+        <p:style>
+          <a:lnRef idx="1">
+            <a:schemeClr val="accent1"/>
+          </a:lnRef>
+          <a:fillRef idx="3">
+            <a:schemeClr val="accent1"/>
+          </a:fillRef>
+          <a:effectRef idx="2">
+            <a:schemeClr val="accent1"/>
+          </a:effectRef>
+          <a:fontRef idx="minor">
+            <a:schemeClr val="lt1"/>
+          </a:fontRef>
+        </p:style>
+        <p:txBody>
+          <a:bodyPr rtlCol="0" anchor="ctr"/>
+          <a:lstStyle/>
+          <a:p>
+            <a:pPr algn="ctr"/>
+          </a:p>
+        </p:txBody>
+      </p:sp>
       <p:pic>
         <p:nvPicPr>
-          <p:cNvPr id="8" name="Picture 7" descr="shot_07_ghn_dashboard.png"/>
+          <p:cNvPr id="9" name="Picture 8" descr="shot_07_ghn_dashboard.png"/>
           <p:cNvPicPr>
             <a:picLocks noChangeAspect="1"/>
           </p:cNvPicPr>
@@ -6067,8 +6382,8 @@
         </p:blipFill>
         <p:spPr>
           <a:xfrm>
-            <a:off x="5029200" y="1554480"/>
-            <a:ext cx="6400800" cy="4846320"/>
+            <a:off x="6636849" y="1554480"/>
+            <a:ext cx="3185502" cy="4846320"/>
           </a:xfrm>
           <a:prstGeom prst="rect">
             <a:avLst/>
@@ -6384,9 +6699,54 @@
           </a:p>
         </p:txBody>
       </p:sp>
+      <p:sp>
+        <p:nvSpPr>
+          <p:cNvPr id="8" name="Rounded Rectangle 7"/>
+          <p:cNvSpPr/>
+          <p:nvPr/>
+        </p:nvSpPr>
+        <p:spPr>
+          <a:xfrm>
+            <a:off x="5029200" y="1554480"/>
+            <a:ext cx="6400800" cy="4846320"/>
+          </a:xfrm>
+          <a:prstGeom prst="roundRect">
+            <a:avLst/>
+          </a:prstGeom>
+          <a:solidFill>
+            <a:srgbClr val="F1F5F9"/>
+          </a:solidFill>
+          <a:ln>
+            <a:solidFill>
+              <a:srgbClr val="E2E8F0"/>
+            </a:solidFill>
+          </a:ln>
+        </p:spPr>
+        <p:style>
+          <a:lnRef idx="1">
+            <a:schemeClr val="accent1"/>
+          </a:lnRef>
+          <a:fillRef idx="3">
+            <a:schemeClr val="accent1"/>
+          </a:fillRef>
+          <a:effectRef idx="2">
+            <a:schemeClr val="accent1"/>
+          </a:effectRef>
+          <a:fontRef idx="minor">
+            <a:schemeClr val="lt1"/>
+          </a:fontRef>
+        </p:style>
+        <p:txBody>
+          <a:bodyPr rtlCol="0" anchor="ctr"/>
+          <a:lstStyle/>
+          <a:p>
+            <a:pPr algn="ctr"/>
+          </a:p>
+        </p:txBody>
+      </p:sp>
       <p:pic>
         <p:nvPicPr>
-          <p:cNvPr id="8" name="Picture 7" descr="shot_08_ghn_print_slip.png"/>
+          <p:cNvPr id="9" name="Picture 8" descr="shot_08_ghn_print_slip.png"/>
           <p:cNvPicPr>
             <a:picLocks noChangeAspect="1"/>
           </p:cNvPicPr>
@@ -6400,8 +6760,8 @@
         </p:blipFill>
         <p:spPr>
           <a:xfrm>
-            <a:off x="5029200" y="1554480"/>
-            <a:ext cx="6400800" cy="4846320"/>
+            <a:off x="5029200" y="2602468"/>
+            <a:ext cx="6400800" cy="2750343"/>
           </a:xfrm>
           <a:prstGeom prst="rect">
             <a:avLst/>

</xml_diff>